<commit_message>
Remove slide 5 to maintain exact 4-slide format matching document pages
</commit_message>
<xml_diff>
--- a/bus-app-presentation.pptx
+++ b/bus-app-presentation.pptx
@@ -9,7 +9,6 @@
     <p:sldId id="257" r:id="rId8"/>
     <p:sldId id="258" r:id="rId9"/>
     <p:sldId id="259" r:id="rId10"/>
-    <p:sldId id="260" r:id="rId11"/>
   </p:sldIdLst>
   <p:sldSz cx="12191695" cy="6858000" type="screen4x3"/>
   <p:notesSz cx="6858000" cy="9144000"/>
@@ -9681,540 +9680,6 @@
                 <a:latin typeface="Segoe UI"/>
               </a:rPr>
               <a:t>من «كتابة يدوية ومعلومة مفقودة» إلى «نشر بضغطة، متابعة لايف، وقرارات مبنية على أرقام حقيقية» مع حماية دخل الاشتراكات.</a:t>
-            </a:r>
-          </a:p>
-        </p:txBody>
-      </p:sp>
-    </p:spTree>
-  </p:cSld>
-  <p:clrMapOvr>
-    <a:masterClrMapping/>
-  </p:clrMapOvr>
-</p:sld>
-</file>
-
-<file path=ppt/slides/slide5.xml><?xml version="1.0" encoding="utf-8"?>
-<p:sld xmlns:a="http://schemas.openxmlformats.org/drawingml/2006/main" xmlns:p="http://schemas.openxmlformats.org/presentationml/2006/main" xmlns:r="http://schemas.openxmlformats.org/officeDocument/2006/relationships">
-  <p:cSld>
-    <p:spTree>
-      <p:nvGrpSpPr>
-        <p:cNvPr id="1" name=""/>
-        <p:cNvGrpSpPr/>
-        <p:nvPr/>
-      </p:nvGrpSpPr>
-      <p:grpSpPr/>
-      <p:sp>
-        <p:nvSpPr>
-          <p:cNvPr id="2" name="Rectangle 1"/>
-          <p:cNvSpPr/>
-          <p:nvPr/>
-        </p:nvSpPr>
-        <p:spPr>
-          <a:xfrm>
-            <a:off x="0" y="0"/>
-            <a:ext cx="12191695" cy="6858000"/>
-          </a:xfrm>
-          <a:prstGeom prst="rect">
-            <a:avLst/>
-          </a:prstGeom>
-          <a:solidFill>
-            <a:srgbClr val="072040"/>
-          </a:solidFill>
-          <a:ln>
-            <a:noFill/>
-          </a:ln>
-        </p:spPr>
-        <p:style>
-          <a:lnRef idx="1">
-            <a:schemeClr val="accent1"/>
-          </a:lnRef>
-          <a:fillRef idx="3">
-            <a:schemeClr val="accent1"/>
-          </a:fillRef>
-          <a:effectRef idx="2">
-            <a:schemeClr val="accent1"/>
-          </a:effectRef>
-          <a:fontRef idx="minor">
-            <a:schemeClr val="lt1"/>
-          </a:fontRef>
-        </p:style>
-        <p:txBody>
-          <a:bodyPr rtlCol="0" anchor="ctr"/>
-          <a:lstStyle/>
-          <a:p>
-            <a:pPr algn="ctr"/>
-          </a:p>
-        </p:txBody>
-      </p:sp>
-      <p:sp>
-        <p:nvSpPr>
-          <p:cNvPr id="3" name="Rectangle 2"/>
-          <p:cNvSpPr/>
-          <p:nvPr/>
-        </p:nvSpPr>
-        <p:spPr>
-          <a:xfrm>
-            <a:off x="0" y="0"/>
-            <a:ext cx="12191695" cy="109728"/>
-          </a:xfrm>
-          <a:prstGeom prst="rect">
-            <a:avLst/>
-          </a:prstGeom>
-          <a:solidFill>
-            <a:srgbClr val="12806A"/>
-          </a:solidFill>
-          <a:ln>
-            <a:noFill/>
-          </a:ln>
-        </p:spPr>
-        <p:style>
-          <a:lnRef idx="1">
-            <a:schemeClr val="accent1"/>
-          </a:lnRef>
-          <a:fillRef idx="3">
-            <a:schemeClr val="accent1"/>
-          </a:fillRef>
-          <a:effectRef idx="2">
-            <a:schemeClr val="accent1"/>
-          </a:effectRef>
-          <a:fontRef idx="minor">
-            <a:schemeClr val="lt1"/>
-          </a:fontRef>
-        </p:style>
-        <p:txBody>
-          <a:bodyPr rtlCol="0" anchor="ctr"/>
-          <a:lstStyle/>
-          <a:p>
-            <a:pPr algn="ctr"/>
-          </a:p>
-        </p:txBody>
-      </p:sp>
-      <p:sp>
-        <p:nvSpPr>
-          <p:cNvPr id="4" name="TextBox 3"/>
-          <p:cNvSpPr txBox="1"/>
-          <p:nvPr/>
-        </p:nvSpPr>
-        <p:spPr>
-          <a:xfrm>
-            <a:off x="1828800" y="1097280"/>
-            <a:ext cx="8534095" cy="4572000"/>
-          </a:xfrm>
-          <a:prstGeom prst="rect">
-            <a:avLst/>
-          </a:prstGeom>
-          <a:noFill/>
-        </p:spPr>
-        <p:txBody>
-          <a:bodyPr wrap="square" lIns="0" tIns="0" rIns="0" bIns="0">
-            <a:spAutoFit/>
-          </a:bodyPr>
-          <a:lstStyle/>
-          <a:p>
-            <a:pPr algn="ctr">
-              <a:spcAft>
-                <a:spcPts val="1000"/>
-              </a:spcAft>
-            </a:pPr>
-            <a:r>
-              <a:rPr sz="4400" b="1">
-                <a:solidFill>
-                  <a:srgbClr val="FFFFFF"/>
-                </a:solidFill>
-                <a:latin typeface="Segoe UI"/>
-              </a:rPr>
-              <a:t>Movia Bus</a:t>
-            </a:r>
-          </a:p>
-          <a:p>
-            <a:pPr algn="ctr">
-              <a:spcAft>
-                <a:spcPts val="1400"/>
-              </a:spcAft>
-            </a:pPr>
-            <a:r>
-              <a:rPr sz="3200" b="1">
-                <a:solidFill>
-                  <a:srgbClr val="7FF0CF"/>
-                </a:solidFill>
-                <a:latin typeface="Segoe UI"/>
-              </a:rPr>
-              <a:t>شكراً لحسن استماعكم</a:t>
-            </a:r>
-          </a:p>
-          <a:p>
-            <a:pPr algn="ctr">
-              <a:spcAft>
-                <a:spcPts val="2800"/>
-              </a:spcAft>
-            </a:pPr>
-            <a:r>
-              <a:rPr sz="1800">
-                <a:solidFill>
-                  <a:srgbClr val="DCEBF8"/>
-                </a:solidFill>
-                <a:latin typeface="Segoe UI"/>
-              </a:rPr>
-              <a:t>نسعد باستقبال أسئلتكم واستفساراتكم حول المشروع</a:t>
-            </a:r>
-          </a:p>
-        </p:txBody>
-      </p:sp>
-      <p:sp>
-        <p:nvSpPr>
-          <p:cNvPr id="5" name="Rounded Rectangle 4"/>
-          <p:cNvSpPr/>
-          <p:nvPr/>
-        </p:nvSpPr>
-        <p:spPr>
-          <a:xfrm>
-            <a:off x="7543800" y="3931920"/>
-            <a:ext cx="2377440" cy="594360"/>
-          </a:xfrm>
-          <a:prstGeom prst="roundRect">
-            <a:avLst/>
-          </a:prstGeom>
-          <a:solidFill>
-            <a:srgbClr val="103660"/>
-          </a:solidFill>
-          <a:ln w="15240">
-            <a:solidFill>
-              <a:srgbClr val="235F9B"/>
-            </a:solidFill>
-          </a:ln>
-        </p:spPr>
-        <p:style>
-          <a:lnRef idx="1">
-            <a:schemeClr val="accent1"/>
-          </a:lnRef>
-          <a:fillRef idx="3">
-            <a:schemeClr val="accent1"/>
-          </a:fillRef>
-          <a:effectRef idx="2">
-            <a:schemeClr val="accent1"/>
-          </a:effectRef>
-          <a:fontRef idx="minor">
-            <a:schemeClr val="lt1"/>
-          </a:fontRef>
-        </p:style>
-        <p:txBody>
-          <a:bodyPr rtlCol="0" anchor="ctr"/>
-          <a:lstStyle/>
-          <a:p>
-            <a:pPr algn="ctr"/>
-            <a:r>
-              <a:rPr sz="1300" b="1">
-                <a:solidFill>
-                  <a:srgbClr val="FFFFFF"/>
-                </a:solidFill>
-                <a:latin typeface="Segoe UI"/>
-              </a:rPr>
-              <a:t>حسن ممدوح</a:t>
-            </a:r>
-          </a:p>
-        </p:txBody>
-      </p:sp>
-      <p:sp>
-        <p:nvSpPr>
-          <p:cNvPr id="6" name="Rounded Rectangle 5"/>
-          <p:cNvSpPr/>
-          <p:nvPr/>
-        </p:nvSpPr>
-        <p:spPr>
-          <a:xfrm>
-            <a:off x="4892040" y="3931920"/>
-            <a:ext cx="2377440" cy="594360"/>
-          </a:xfrm>
-          <a:prstGeom prst="roundRect">
-            <a:avLst/>
-          </a:prstGeom>
-          <a:solidFill>
-            <a:srgbClr val="103660"/>
-          </a:solidFill>
-          <a:ln w="15240">
-            <a:solidFill>
-              <a:srgbClr val="235F9B"/>
-            </a:solidFill>
-          </a:ln>
-        </p:spPr>
-        <p:style>
-          <a:lnRef idx="1">
-            <a:schemeClr val="accent1"/>
-          </a:lnRef>
-          <a:fillRef idx="3">
-            <a:schemeClr val="accent1"/>
-          </a:fillRef>
-          <a:effectRef idx="2">
-            <a:schemeClr val="accent1"/>
-          </a:effectRef>
-          <a:fontRef idx="minor">
-            <a:schemeClr val="lt1"/>
-          </a:fontRef>
-        </p:style>
-        <p:txBody>
-          <a:bodyPr rtlCol="0" anchor="ctr"/>
-          <a:lstStyle/>
-          <a:p>
-            <a:pPr algn="ctr"/>
-            <a:r>
-              <a:rPr sz="1300" b="1">
-                <a:solidFill>
-                  <a:srgbClr val="FFFFFF"/>
-                </a:solidFill>
-                <a:latin typeface="Segoe UI"/>
-              </a:rPr>
-              <a:t>محمد شحاته</a:t>
-            </a:r>
-          </a:p>
-        </p:txBody>
-      </p:sp>
-      <p:sp>
-        <p:nvSpPr>
-          <p:cNvPr id="7" name="Rounded Rectangle 6"/>
-          <p:cNvSpPr/>
-          <p:nvPr/>
-        </p:nvSpPr>
-        <p:spPr>
-          <a:xfrm>
-            <a:off x="2240280" y="3931920"/>
-            <a:ext cx="2377440" cy="594360"/>
-          </a:xfrm>
-          <a:prstGeom prst="roundRect">
-            <a:avLst/>
-          </a:prstGeom>
-          <a:solidFill>
-            <a:srgbClr val="103660"/>
-          </a:solidFill>
-          <a:ln w="15240">
-            <a:solidFill>
-              <a:srgbClr val="235F9B"/>
-            </a:solidFill>
-          </a:ln>
-        </p:spPr>
-        <p:style>
-          <a:lnRef idx="1">
-            <a:schemeClr val="accent1"/>
-          </a:lnRef>
-          <a:fillRef idx="3">
-            <a:schemeClr val="accent1"/>
-          </a:fillRef>
-          <a:effectRef idx="2">
-            <a:schemeClr val="accent1"/>
-          </a:effectRef>
-          <a:fontRef idx="minor">
-            <a:schemeClr val="lt1"/>
-          </a:fontRef>
-        </p:style>
-        <p:txBody>
-          <a:bodyPr rtlCol="0" anchor="ctr"/>
-          <a:lstStyle/>
-          <a:p>
-            <a:pPr algn="ctr"/>
-            <a:r>
-              <a:rPr sz="1300" b="1">
-                <a:solidFill>
-                  <a:srgbClr val="FFFFFF"/>
-                </a:solidFill>
-                <a:latin typeface="Segoe UI"/>
-              </a:rPr>
-              <a:t>أحمد عصام</a:t>
-            </a:r>
-          </a:p>
-        </p:txBody>
-      </p:sp>
-      <p:sp>
-        <p:nvSpPr>
-          <p:cNvPr id="8" name="Rounded Rectangle 7"/>
-          <p:cNvSpPr/>
-          <p:nvPr/>
-        </p:nvSpPr>
-        <p:spPr>
-          <a:xfrm>
-            <a:off x="7543800" y="4709160"/>
-            <a:ext cx="2377440" cy="594360"/>
-          </a:xfrm>
-          <a:prstGeom prst="roundRect">
-            <a:avLst/>
-          </a:prstGeom>
-          <a:solidFill>
-            <a:srgbClr val="103660"/>
-          </a:solidFill>
-          <a:ln w="15240">
-            <a:solidFill>
-              <a:srgbClr val="235F9B"/>
-            </a:solidFill>
-          </a:ln>
-        </p:spPr>
-        <p:style>
-          <a:lnRef idx="1">
-            <a:schemeClr val="accent1"/>
-          </a:lnRef>
-          <a:fillRef idx="3">
-            <a:schemeClr val="accent1"/>
-          </a:fillRef>
-          <a:effectRef idx="2">
-            <a:schemeClr val="accent1"/>
-          </a:effectRef>
-          <a:fontRef idx="minor">
-            <a:schemeClr val="lt1"/>
-          </a:fontRef>
-        </p:style>
-        <p:txBody>
-          <a:bodyPr rtlCol="0" anchor="ctr"/>
-          <a:lstStyle/>
-          <a:p>
-            <a:pPr algn="ctr"/>
-            <a:r>
-              <a:rPr sz="1300" b="1">
-                <a:solidFill>
-                  <a:srgbClr val="FFFFFF"/>
-                </a:solidFill>
-                <a:latin typeface="Segoe UI"/>
-              </a:rPr>
-              <a:t>عبدالله جمال</a:t>
-            </a:r>
-          </a:p>
-        </p:txBody>
-      </p:sp>
-      <p:sp>
-        <p:nvSpPr>
-          <p:cNvPr id="9" name="Rounded Rectangle 8"/>
-          <p:cNvSpPr/>
-          <p:nvPr/>
-        </p:nvSpPr>
-        <p:spPr>
-          <a:xfrm>
-            <a:off x="4892040" y="4709160"/>
-            <a:ext cx="2377440" cy="594360"/>
-          </a:xfrm>
-          <a:prstGeom prst="roundRect">
-            <a:avLst/>
-          </a:prstGeom>
-          <a:solidFill>
-            <a:srgbClr val="103660"/>
-          </a:solidFill>
-          <a:ln w="15240">
-            <a:solidFill>
-              <a:srgbClr val="235F9B"/>
-            </a:solidFill>
-          </a:ln>
-        </p:spPr>
-        <p:style>
-          <a:lnRef idx="1">
-            <a:schemeClr val="accent1"/>
-          </a:lnRef>
-          <a:fillRef idx="3">
-            <a:schemeClr val="accent1"/>
-          </a:fillRef>
-          <a:effectRef idx="2">
-            <a:schemeClr val="accent1"/>
-          </a:effectRef>
-          <a:fontRef idx="minor">
-            <a:schemeClr val="lt1"/>
-          </a:fontRef>
-        </p:style>
-        <p:txBody>
-          <a:bodyPr rtlCol="0" anchor="ctr"/>
-          <a:lstStyle/>
-          <a:p>
-            <a:pPr algn="ctr"/>
-            <a:r>
-              <a:rPr sz="1300" b="1">
-                <a:solidFill>
-                  <a:srgbClr val="FFFFFF"/>
-                </a:solidFill>
-                <a:latin typeface="Segoe UI"/>
-              </a:rPr>
-              <a:t>مولر باسم</a:t>
-            </a:r>
-          </a:p>
-        </p:txBody>
-      </p:sp>
-      <p:sp>
-        <p:nvSpPr>
-          <p:cNvPr id="10" name="Rounded Rectangle 9"/>
-          <p:cNvSpPr/>
-          <p:nvPr/>
-        </p:nvSpPr>
-        <p:spPr>
-          <a:xfrm>
-            <a:off x="2240280" y="4709160"/>
-            <a:ext cx="2377440" cy="594360"/>
-          </a:xfrm>
-          <a:prstGeom prst="roundRect">
-            <a:avLst/>
-          </a:prstGeom>
-          <a:solidFill>
-            <a:srgbClr val="103660"/>
-          </a:solidFill>
-          <a:ln w="15240">
-            <a:solidFill>
-              <a:srgbClr val="235F9B"/>
-            </a:solidFill>
-          </a:ln>
-        </p:spPr>
-        <p:style>
-          <a:lnRef idx="1">
-            <a:schemeClr val="accent1"/>
-          </a:lnRef>
-          <a:fillRef idx="3">
-            <a:schemeClr val="accent1"/>
-          </a:fillRef>
-          <a:effectRef idx="2">
-            <a:schemeClr val="accent1"/>
-          </a:effectRef>
-          <a:fontRef idx="minor">
-            <a:schemeClr val="lt1"/>
-          </a:fontRef>
-        </p:style>
-        <p:txBody>
-          <a:bodyPr rtlCol="0" anchor="ctr"/>
-          <a:lstStyle/>
-          <a:p>
-            <a:pPr algn="ctr"/>
-            <a:r>
-              <a:rPr sz="1300" b="1">
-                <a:solidFill>
-                  <a:srgbClr val="FFFFFF"/>
-                </a:solidFill>
-                <a:latin typeface="Segoe UI"/>
-              </a:rPr>
-              <a:t>كيرلس سمير</a:t>
-            </a:r>
-          </a:p>
-        </p:txBody>
-      </p:sp>
-      <p:sp>
-        <p:nvSpPr>
-          <p:cNvPr id="11" name="TextBox 10"/>
-          <p:cNvSpPr txBox="1"/>
-          <p:nvPr/>
-        </p:nvSpPr>
-        <p:spPr>
-          <a:xfrm>
-            <a:off x="1828800" y="5623560"/>
-            <a:ext cx="8534095" cy="411480"/>
-          </a:xfrm>
-          <a:prstGeom prst="rect">
-            <a:avLst/>
-          </a:prstGeom>
-          <a:noFill/>
-        </p:spPr>
-        <p:txBody>
-          <a:bodyPr wrap="none">
-            <a:spAutoFit/>
-          </a:bodyPr>
-          <a:lstStyle/>
-          <a:p>
-            <a:pPr algn="ctr"/>
-            <a:r>
-              <a:rPr sz="1300" b="1">
-                <a:solidFill>
-                  <a:srgbClr val="7FF0CF"/>
-                </a:solidFill>
-                <a:latin typeface="Segoe UI"/>
-              </a:rPr>
-              <a:t>جامعة اللوتس — المنيا الجديدة</a:t>
             </a:r>
           </a:p>
         </p:txBody>

</xml_diff>

<commit_message>
Remove 3 pillar cards from Slide 1 cover for clean minimalist layout
</commit_message>
<xml_diff>
--- a/bus-app-presentation.pptx
+++ b/bus-app-presentation.pptx
@@ -3185,8 +3185,8 @@
         </p:nvSpPr>
         <p:spPr>
           <a:xfrm>
-            <a:off x="5212080" y="777240"/>
-            <a:ext cx="6217920" cy="3383280"/>
+            <a:off x="5212080" y="1371600"/>
+            <a:ext cx="6217920" cy="4114800"/>
           </a:xfrm>
           <a:prstGeom prst="rect">
             <a:avLst/>
@@ -3201,11 +3201,11 @@
           <a:p>
             <a:pPr algn="r" rtl="1">
               <a:spcAft>
-                <a:spcPts val="800"/>
+                <a:spcPts val="1000"/>
               </a:spcAft>
             </a:pPr>
             <a:r>
-              <a:rPr sz="1200" b="1">
+              <a:rPr sz="1300" b="1">
                 <a:solidFill>
                   <a:srgbClr val="7FF0CF"/>
                 </a:solidFill>
@@ -3217,11 +3217,11 @@
           <a:p>
             <a:pPr algn="r" rtl="1">
               <a:spcAft>
-                <a:spcPts val="200"/>
+                <a:spcPts val="400"/>
               </a:spcAft>
             </a:pPr>
             <a:r>
-              <a:rPr sz="4600" b="1">
+              <a:rPr sz="5000" b="1">
                 <a:solidFill>
                   <a:srgbClr val="FFFFFF"/>
                 </a:solidFill>
@@ -3233,11 +3233,11 @@
           <a:p>
             <a:pPr algn="r" rtl="1">
               <a:spcAft>
-                <a:spcPts val="1400"/>
+                <a:spcPts val="1800"/>
               </a:spcAft>
             </a:pPr>
             <a:r>
-              <a:rPr sz="2800" b="1">
+              <a:rPr sz="3200" b="1">
                 <a:solidFill>
                   <a:srgbClr val="7FF0CF"/>
                 </a:solidFill>
@@ -3249,13 +3249,13 @@
           <a:p>
             <a:pPr algn="r" rtl="1"/>
             <a:r>
-              <a:rPr sz="1300">
+              <a:rPr sz="1400">
                 <a:solidFill>
                   <a:srgbClr val="DCEBF8"/>
                 </a:solidFill>
                 <a:latin typeface="Segoe UI"/>
               </a:rPr>
-              <a:t>نظام متكامل يربط ثلاثة أطراف في تجربة نقل جامعي حديثة: الطالب يتابع ويحجز بسهولة، السائق يشغّل ويرى الطلب لايف، والإدارة تتحكم وتتابع بالأرقام والتقارير الحية.</a:t>
+              <a:t>نظام متكامل يربط ثلاثة أطراف في تجربة نقل جامعي حديثة ومريحة: الطالب يتابع ويحجز بسهولة، السائق يشغّل ويرى الطلب لايف، والإدارة تتحكم وتتابع بالأرقام والتقارير الحية.</a:t>
             </a:r>
           </a:p>
         </p:txBody>
@@ -3268,8 +3268,8 @@
         </p:nvSpPr>
         <p:spPr>
           <a:xfrm>
-            <a:off x="9473184" y="4480560"/>
-            <a:ext cx="1947672" cy="1371600"/>
+            <a:off x="731520" y="1005840"/>
+            <a:ext cx="4114800" cy="4846320"/>
           </a:xfrm>
           <a:prstGeom prst="roundRect">
             <a:avLst/>
@@ -3298,74 +3298,84 @@
           </a:fontRef>
         </p:style>
         <p:txBody>
-          <a:bodyPr rtlCol="0" anchor="ctr" lIns="109728" rIns="109728" tIns="137160"/>
-          <a:lstStyle/>
-          <a:p>
-            <a:pPr algn="r" rtl="1">
+          <a:bodyPr rtlCol="0" anchor="ctr"/>
+          <a:lstStyle/>
+          <a:p>
+            <a:pPr algn="ctr"/>
+          </a:p>
+        </p:txBody>
+      </p:sp>
+      <p:sp>
+        <p:nvSpPr>
+          <p:cNvPr id="6" name="TextBox 5"/>
+          <p:cNvSpPr txBox="1"/>
+          <p:nvPr/>
+        </p:nvSpPr>
+        <p:spPr>
+          <a:xfrm>
+            <a:off x="914400" y="1188720"/>
+            <a:ext cx="3749039" cy="777240"/>
+          </a:xfrm>
+          <a:prstGeom prst="rect">
+            <a:avLst/>
+          </a:prstGeom>
+          <a:noFill/>
+        </p:spPr>
+        <p:txBody>
+          <a:bodyPr wrap="none" lIns="0" tIns="0" rIns="0" bIns="0">
+            <a:spAutoFit/>
+          </a:bodyPr>
+          <a:lstStyle/>
+          <a:p>
+            <a:pPr algn="ctr">
               <a:spcAft>
-                <a:spcPts val="400"/>
+                <a:spcPts val="200"/>
               </a:spcAft>
             </a:pPr>
             <a:r>
-              <a:rPr sz="1100" b="1">
-                <a:solidFill>
-                  <a:srgbClr val="12806A"/>
-                </a:solidFill>
-                <a:latin typeface="Segoe UI"/>
-              </a:rPr>
-              <a:t>القسم 1</a:t>
-            </a:r>
-          </a:p>
-          <a:p>
-            <a:pPr algn="r" rtl="1">
-              <a:spcAft>
-                <a:spcPts val="400"/>
-              </a:spcAft>
-            </a:pPr>
-            <a:r>
-              <a:rPr sz="1300" b="1">
-                <a:solidFill>
-                  <a:srgbClr val="FFFFFF"/>
-                </a:solidFill>
-                <a:latin typeface="Segoe UI"/>
-              </a:rPr>
-              <a:t>تجربة الطالب</a:t>
-            </a:r>
-          </a:p>
-          <a:p>
-            <a:pPr algn="r" rtl="1"/>
-            <a:r>
-              <a:rPr sz="950">
-                <a:solidFill>
-                  <a:srgbClr val="B4CDE6"/>
-                </a:solidFill>
-                <a:latin typeface="Segoe UI"/>
-              </a:rPr>
-              <a:t>15 ميزة حصرية وأساسية</a:t>
-            </a:r>
-          </a:p>
-        </p:txBody>
-      </p:sp>
-      <p:sp>
-        <p:nvSpPr>
-          <p:cNvPr id="6" name="Rounded Rectangle 5"/>
+              <a:rPr sz="1900" b="1">
+                <a:solidFill>
+                  <a:srgbClr val="7FF0CF"/>
+                </a:solidFill>
+                <a:latin typeface="Segoe UI"/>
+              </a:rPr>
+              <a:t>فريق العمل</a:t>
+            </a:r>
+          </a:p>
+          <a:p>
+            <a:pPr algn="ctr"/>
+            <a:r>
+              <a:rPr sz="1100">
+                <a:solidFill>
+                  <a:srgbClr val="B4D2EB"/>
+                </a:solidFill>
+                <a:latin typeface="Segoe UI"/>
+              </a:rPr>
+              <a:t>مشروع نظام إدارة وتتبع حافلات الطلاب</a:t>
+            </a:r>
+          </a:p>
+        </p:txBody>
+      </p:sp>
+      <p:sp>
+        <p:nvSpPr>
+          <p:cNvPr id="7" name="Rounded Rectangle 6"/>
           <p:cNvSpPr/>
           <p:nvPr/>
         </p:nvSpPr>
         <p:spPr>
           <a:xfrm>
-            <a:off x="7342632" y="4480560"/>
-            <a:ext cx="1947672" cy="1371600"/>
+            <a:off x="2871216" y="2148840"/>
+            <a:ext cx="1737360" cy="658368"/>
           </a:xfrm>
           <a:prstGeom prst="roundRect">
             <a:avLst/>
           </a:prstGeom>
           <a:solidFill>
-            <a:srgbClr val="0D3058"/>
-          </a:solidFill>
-          <a:ln w="19050">
+            <a:srgbClr val="123A66"/>
+          </a:solidFill>
+          <a:ln w="15240">
             <a:solidFill>
-              <a:srgbClr val="194B7D"/>
+              <a:srgbClr val="235F9B"/>
             </a:solidFill>
           </a:ln>
         </p:spPr>
@@ -3384,74 +3394,42 @@
           </a:fontRef>
         </p:style>
         <p:txBody>
-          <a:bodyPr rtlCol="0" anchor="ctr" lIns="109728" rIns="109728" tIns="137160"/>
-          <a:lstStyle/>
-          <a:p>
-            <a:pPr algn="r" rtl="1">
-              <a:spcAft>
-                <a:spcPts val="400"/>
-              </a:spcAft>
-            </a:pPr>
-            <a:r>
-              <a:rPr sz="1100" b="1">
-                <a:solidFill>
-                  <a:srgbClr val="1D5A99"/>
-                </a:solidFill>
-                <a:latin typeface="Segoe UI"/>
-              </a:rPr>
-              <a:t>القسم 2</a:t>
-            </a:r>
-          </a:p>
-          <a:p>
-            <a:pPr algn="r" rtl="1">
-              <a:spcAft>
-                <a:spcPts val="400"/>
-              </a:spcAft>
-            </a:pPr>
-            <a:r>
-              <a:rPr sz="1300" b="1">
+          <a:bodyPr rtlCol="0" anchor="ctr"/>
+          <a:lstStyle/>
+          <a:p>
+            <a:pPr algn="ctr"/>
+            <a:r>
+              <a:rPr sz="1350" b="1">
                 <a:solidFill>
                   <a:srgbClr val="FFFFFF"/>
                 </a:solidFill>
                 <a:latin typeface="Segoe UI"/>
               </a:rPr>
-              <a:t>تجربة السائق</a:t>
-            </a:r>
-          </a:p>
-          <a:p>
-            <a:pPr algn="r" rtl="1"/>
-            <a:r>
-              <a:rPr sz="950">
-                <a:solidFill>
-                  <a:srgbClr val="B4CDE6"/>
-                </a:solidFill>
-                <a:latin typeface="Segoe UI"/>
-              </a:rPr>
-              <a:t>9 ميزات تشغيل بدون مكالمات</a:t>
-            </a:r>
-          </a:p>
-        </p:txBody>
-      </p:sp>
-      <p:sp>
-        <p:nvSpPr>
-          <p:cNvPr id="7" name="Rounded Rectangle 6"/>
+              <a:t>حسن ممدوح</a:t>
+            </a:r>
+          </a:p>
+        </p:txBody>
+      </p:sp>
+      <p:sp>
+        <p:nvSpPr>
+          <p:cNvPr id="8" name="Rounded Rectangle 7"/>
           <p:cNvSpPr/>
           <p:nvPr/>
         </p:nvSpPr>
         <p:spPr>
           <a:xfrm>
-            <a:off x="5212080" y="4480560"/>
-            <a:ext cx="1947672" cy="1371600"/>
+            <a:off x="969264" y="2148840"/>
+            <a:ext cx="1737360" cy="658368"/>
           </a:xfrm>
           <a:prstGeom prst="roundRect">
             <a:avLst/>
           </a:prstGeom>
           <a:solidFill>
-            <a:srgbClr val="0D3058"/>
-          </a:solidFill>
-          <a:ln w="19050">
+            <a:srgbClr val="123A66"/>
+          </a:solidFill>
+          <a:ln w="15240">
             <a:solidFill>
-              <a:srgbClr val="194B7D"/>
+              <a:srgbClr val="235F9B"/>
             </a:solidFill>
           </a:ln>
         </p:spPr>
@@ -3470,74 +3448,42 @@
           </a:fontRef>
         </p:style>
         <p:txBody>
-          <a:bodyPr rtlCol="0" anchor="ctr" lIns="109728" rIns="109728" tIns="137160"/>
-          <a:lstStyle/>
-          <a:p>
-            <a:pPr algn="r" rtl="1">
-              <a:spcAft>
-                <a:spcPts val="400"/>
-              </a:spcAft>
-            </a:pPr>
-            <a:r>
-              <a:rPr sz="1100" b="1">
-                <a:solidFill>
-                  <a:srgbClr val="C8930C"/>
-                </a:solidFill>
-                <a:latin typeface="Segoe UI"/>
-              </a:rPr>
-              <a:t>القسم 3</a:t>
-            </a:r>
-          </a:p>
-          <a:p>
-            <a:pPr algn="r" rtl="1">
-              <a:spcAft>
-                <a:spcPts val="400"/>
-              </a:spcAft>
-            </a:pPr>
-            <a:r>
-              <a:rPr sz="1300" b="1">
+          <a:bodyPr rtlCol="0" anchor="ctr"/>
+          <a:lstStyle/>
+          <a:p>
+            <a:pPr algn="ctr"/>
+            <a:r>
+              <a:rPr sz="1350" b="1">
                 <a:solidFill>
                   <a:srgbClr val="FFFFFF"/>
                 </a:solidFill>
                 <a:latin typeface="Segoe UI"/>
               </a:rPr>
-              <a:t>لوحة الإدارة</a:t>
-            </a:r>
-          </a:p>
-          <a:p>
-            <a:pPr algn="r" rtl="1"/>
-            <a:r>
-              <a:rPr sz="950">
-                <a:solidFill>
-                  <a:srgbClr val="B4CDE6"/>
-                </a:solidFill>
-                <a:latin typeface="Segoe UI"/>
-              </a:rPr>
-              <a:t>10 ميزات تحكم وتقارير حية</a:t>
-            </a:r>
-          </a:p>
-        </p:txBody>
-      </p:sp>
-      <p:sp>
-        <p:nvSpPr>
-          <p:cNvPr id="8" name="Rounded Rectangle 7"/>
+              <a:t>محمد شحاته</a:t>
+            </a:r>
+          </a:p>
+        </p:txBody>
+      </p:sp>
+      <p:sp>
+        <p:nvSpPr>
+          <p:cNvPr id="9" name="Rounded Rectangle 8"/>
           <p:cNvSpPr/>
           <p:nvPr/>
         </p:nvSpPr>
         <p:spPr>
           <a:xfrm>
-            <a:off x="731520" y="1005840"/>
-            <a:ext cx="4114800" cy="4846320"/>
+            <a:off x="2871216" y="2971800"/>
+            <a:ext cx="1737360" cy="658368"/>
           </a:xfrm>
           <a:prstGeom prst="roundRect">
             <a:avLst/>
           </a:prstGeom>
           <a:solidFill>
-            <a:srgbClr val="0D3058"/>
-          </a:solidFill>
-          <a:ln w="19050">
+            <a:srgbClr val="123A66"/>
+          </a:solidFill>
+          <a:ln w="15240">
             <a:solidFill>
-              <a:srgbClr val="194B7D"/>
+              <a:srgbClr val="235F9B"/>
             </a:solidFill>
           </a:ln>
         </p:spPr>
@@ -3560,56 +3506,14 @@
           <a:lstStyle/>
           <a:p>
             <a:pPr algn="ctr"/>
-          </a:p>
-        </p:txBody>
-      </p:sp>
-      <p:sp>
-        <p:nvSpPr>
-          <p:cNvPr id="9" name="TextBox 8"/>
-          <p:cNvSpPr txBox="1"/>
-          <p:nvPr/>
-        </p:nvSpPr>
-        <p:spPr>
-          <a:xfrm>
-            <a:off x="914400" y="1188720"/>
-            <a:ext cx="3749039" cy="777240"/>
-          </a:xfrm>
-          <a:prstGeom prst="rect">
-            <a:avLst/>
-          </a:prstGeom>
-          <a:noFill/>
-        </p:spPr>
-        <p:txBody>
-          <a:bodyPr wrap="none" lIns="0" tIns="0" rIns="0" bIns="0">
-            <a:spAutoFit/>
-          </a:bodyPr>
-          <a:lstStyle/>
-          <a:p>
-            <a:pPr algn="ctr">
-              <a:spcAft>
-                <a:spcPts val="200"/>
-              </a:spcAft>
-            </a:pPr>
-            <a:r>
-              <a:rPr sz="1900" b="1">
-                <a:solidFill>
-                  <a:srgbClr val="7FF0CF"/>
-                </a:solidFill>
-                <a:latin typeface="Segoe UI"/>
-              </a:rPr>
-              <a:t>فريق العمل</a:t>
-            </a:r>
-          </a:p>
-          <a:p>
-            <a:pPr algn="ctr"/>
-            <a:r>
-              <a:rPr sz="1100">
-                <a:solidFill>
-                  <a:srgbClr val="B4D2EB"/>
-                </a:solidFill>
-                <a:latin typeface="Segoe UI"/>
-              </a:rPr>
-              <a:t>مشروع نظام إدارة وتتبع حافلات الطلاب</a:t>
+            <a:r>
+              <a:rPr sz="1350" b="1">
+                <a:solidFill>
+                  <a:srgbClr val="FFFFFF"/>
+                </a:solidFill>
+                <a:latin typeface="Segoe UI"/>
+              </a:rPr>
+              <a:t>أحمد عصام</a:t>
             </a:r>
           </a:p>
         </p:txBody>
@@ -3622,7 +3526,7 @@
         </p:nvSpPr>
         <p:spPr>
           <a:xfrm>
-            <a:off x="2871216" y="2148840"/>
+            <a:off x="969264" y="2971800"/>
             <a:ext cx="1737360" cy="658368"/>
           </a:xfrm>
           <a:prstGeom prst="roundRect">
@@ -3663,7 +3567,7 @@
                 </a:solidFill>
                 <a:latin typeface="Segoe UI"/>
               </a:rPr>
-              <a:t>حسن ممدوح</a:t>
+              <a:t>عبدالله جمال</a:t>
             </a:r>
           </a:p>
         </p:txBody>
@@ -3676,7 +3580,7 @@
         </p:nvSpPr>
         <p:spPr>
           <a:xfrm>
-            <a:off x="969264" y="2148840"/>
+            <a:off x="2871216" y="3794760"/>
             <a:ext cx="1737360" cy="658368"/>
           </a:xfrm>
           <a:prstGeom prst="roundRect">
@@ -3717,7 +3621,7 @@
                 </a:solidFill>
                 <a:latin typeface="Segoe UI"/>
               </a:rPr>
-              <a:t>محمد شحاته</a:t>
+              <a:t>مولر باسم</a:t>
             </a:r>
           </a:p>
         </p:txBody>
@@ -3730,7 +3634,7 @@
         </p:nvSpPr>
         <p:spPr>
           <a:xfrm>
-            <a:off x="2871216" y="2971800"/>
+            <a:off x="969264" y="3794760"/>
             <a:ext cx="1737360" cy="658368"/>
           </a:xfrm>
           <a:prstGeom prst="roundRect">
@@ -3771,168 +3675,6 @@
                 </a:solidFill>
                 <a:latin typeface="Segoe UI"/>
               </a:rPr>
-              <a:t>أحمد عصام</a:t>
-            </a:r>
-          </a:p>
-        </p:txBody>
-      </p:sp>
-      <p:sp>
-        <p:nvSpPr>
-          <p:cNvPr id="13" name="Rounded Rectangle 12"/>
-          <p:cNvSpPr/>
-          <p:nvPr/>
-        </p:nvSpPr>
-        <p:spPr>
-          <a:xfrm>
-            <a:off x="969264" y="2971800"/>
-            <a:ext cx="1737360" cy="658368"/>
-          </a:xfrm>
-          <a:prstGeom prst="roundRect">
-            <a:avLst/>
-          </a:prstGeom>
-          <a:solidFill>
-            <a:srgbClr val="123A66"/>
-          </a:solidFill>
-          <a:ln w="15240">
-            <a:solidFill>
-              <a:srgbClr val="235F9B"/>
-            </a:solidFill>
-          </a:ln>
-        </p:spPr>
-        <p:style>
-          <a:lnRef idx="1">
-            <a:schemeClr val="accent1"/>
-          </a:lnRef>
-          <a:fillRef idx="3">
-            <a:schemeClr val="accent1"/>
-          </a:fillRef>
-          <a:effectRef idx="2">
-            <a:schemeClr val="accent1"/>
-          </a:effectRef>
-          <a:fontRef idx="minor">
-            <a:schemeClr val="lt1"/>
-          </a:fontRef>
-        </p:style>
-        <p:txBody>
-          <a:bodyPr rtlCol="0" anchor="ctr"/>
-          <a:lstStyle/>
-          <a:p>
-            <a:pPr algn="ctr"/>
-            <a:r>
-              <a:rPr sz="1350" b="1">
-                <a:solidFill>
-                  <a:srgbClr val="FFFFFF"/>
-                </a:solidFill>
-                <a:latin typeface="Segoe UI"/>
-              </a:rPr>
-              <a:t>عبدالله جمال</a:t>
-            </a:r>
-          </a:p>
-        </p:txBody>
-      </p:sp>
-      <p:sp>
-        <p:nvSpPr>
-          <p:cNvPr id="14" name="Rounded Rectangle 13"/>
-          <p:cNvSpPr/>
-          <p:nvPr/>
-        </p:nvSpPr>
-        <p:spPr>
-          <a:xfrm>
-            <a:off x="2871216" y="3794760"/>
-            <a:ext cx="1737360" cy="658368"/>
-          </a:xfrm>
-          <a:prstGeom prst="roundRect">
-            <a:avLst/>
-          </a:prstGeom>
-          <a:solidFill>
-            <a:srgbClr val="123A66"/>
-          </a:solidFill>
-          <a:ln w="15240">
-            <a:solidFill>
-              <a:srgbClr val="235F9B"/>
-            </a:solidFill>
-          </a:ln>
-        </p:spPr>
-        <p:style>
-          <a:lnRef idx="1">
-            <a:schemeClr val="accent1"/>
-          </a:lnRef>
-          <a:fillRef idx="3">
-            <a:schemeClr val="accent1"/>
-          </a:fillRef>
-          <a:effectRef idx="2">
-            <a:schemeClr val="accent1"/>
-          </a:effectRef>
-          <a:fontRef idx="minor">
-            <a:schemeClr val="lt1"/>
-          </a:fontRef>
-        </p:style>
-        <p:txBody>
-          <a:bodyPr rtlCol="0" anchor="ctr"/>
-          <a:lstStyle/>
-          <a:p>
-            <a:pPr algn="ctr"/>
-            <a:r>
-              <a:rPr sz="1350" b="1">
-                <a:solidFill>
-                  <a:srgbClr val="FFFFFF"/>
-                </a:solidFill>
-                <a:latin typeface="Segoe UI"/>
-              </a:rPr>
-              <a:t>مولر باسم</a:t>
-            </a:r>
-          </a:p>
-        </p:txBody>
-      </p:sp>
-      <p:sp>
-        <p:nvSpPr>
-          <p:cNvPr id="15" name="Rounded Rectangle 14"/>
-          <p:cNvSpPr/>
-          <p:nvPr/>
-        </p:nvSpPr>
-        <p:spPr>
-          <a:xfrm>
-            <a:off x="969264" y="3794760"/>
-            <a:ext cx="1737360" cy="658368"/>
-          </a:xfrm>
-          <a:prstGeom prst="roundRect">
-            <a:avLst/>
-          </a:prstGeom>
-          <a:solidFill>
-            <a:srgbClr val="123A66"/>
-          </a:solidFill>
-          <a:ln w="15240">
-            <a:solidFill>
-              <a:srgbClr val="235F9B"/>
-            </a:solidFill>
-          </a:ln>
-        </p:spPr>
-        <p:style>
-          <a:lnRef idx="1">
-            <a:schemeClr val="accent1"/>
-          </a:lnRef>
-          <a:fillRef idx="3">
-            <a:schemeClr val="accent1"/>
-          </a:fillRef>
-          <a:effectRef idx="2">
-            <a:schemeClr val="accent1"/>
-          </a:effectRef>
-          <a:fontRef idx="minor">
-            <a:schemeClr val="lt1"/>
-          </a:fontRef>
-        </p:style>
-        <p:txBody>
-          <a:bodyPr rtlCol="0" anchor="ctr"/>
-          <a:lstStyle/>
-          <a:p>
-            <a:pPr algn="ctr"/>
-            <a:r>
-              <a:rPr sz="1350" b="1">
-                <a:solidFill>
-                  <a:srgbClr val="FFFFFF"/>
-                </a:solidFill>
-                <a:latin typeface="Segoe UI"/>
-              </a:rPr>
               <a:t>كيرلس سمير</a:t>
             </a:r>
           </a:p>
@@ -3940,7 +3682,7 @@
       </p:sp>
       <p:sp>
         <p:nvSpPr>
-          <p:cNvPr id="16" name="TextBox 15"/>
+          <p:cNvPr id="13" name="TextBox 12"/>
           <p:cNvSpPr txBox="1"/>
           <p:nvPr/>
         </p:nvSpPr>

</xml_diff>

<commit_message>
Remove top header tagline from Slide 1 cover
</commit_message>
<xml_diff>
--- a/bus-app-presentation.pptx
+++ b/bus-app-presentation.pptx
@@ -3185,8 +3185,8 @@
         </p:nvSpPr>
         <p:spPr>
           <a:xfrm>
-            <a:off x="5212080" y="1371600"/>
-            <a:ext cx="6217920" cy="4114800"/>
+            <a:off x="5212080" y="1645920"/>
+            <a:ext cx="6217920" cy="3840480"/>
           </a:xfrm>
           <a:prstGeom prst="rect">
             <a:avLst/>
@@ -3198,22 +3198,6 @@
             <a:spAutoFit/>
           </a:bodyPr>
           <a:lstStyle/>
-          <a:p>
-            <a:pPr algn="r" rtl="1">
-              <a:spcAft>
-                <a:spcPts val="1000"/>
-              </a:spcAft>
-            </a:pPr>
-            <a:r>
-              <a:rPr sz="1300" b="1">
-                <a:solidFill>
-                  <a:srgbClr val="7FF0CF"/>
-                </a:solidFill>
-                <a:latin typeface="Segoe UI"/>
-              </a:rPr>
-              <a:t>دليل المميزات الشامل — منظومة النقل الذكي</a:t>
-            </a:r>
-          </a:p>
           <a:p>
             <a:pPr algn="r" rtl="1">
               <a:spcAft>
@@ -3221,7 +3205,7 @@
               </a:spcAft>
             </a:pPr>
             <a:r>
-              <a:rPr sz="5000" b="1">
+              <a:rPr sz="5400" b="1">
                 <a:solidFill>
                   <a:srgbClr val="FFFFFF"/>
                 </a:solidFill>
@@ -3233,7 +3217,7 @@
           <a:p>
             <a:pPr algn="r" rtl="1">
               <a:spcAft>
-                <a:spcPts val="1800"/>
+                <a:spcPts val="2000"/>
               </a:spcAft>
             </a:pPr>
             <a:r>

</xml_diff>

<commit_message>
Update team members order to vertical column reading (Right: Hassan, Mohamed, Ahmed; Left: Abdallah, Moeller, Kirollos)
</commit_message>
<xml_diff>
--- a/bus-app-presentation.pptx
+++ b/bus-app-presentation.pptx
@@ -3402,7 +3402,7 @@
         </p:nvSpPr>
         <p:spPr>
           <a:xfrm>
-            <a:off x="969264" y="2148840"/>
+            <a:off x="2871216" y="2971800"/>
             <a:ext cx="1737360" cy="658368"/>
           </a:xfrm>
           <a:prstGeom prst="roundRect">
@@ -3456,7 +3456,7 @@
         </p:nvSpPr>
         <p:spPr>
           <a:xfrm>
-            <a:off x="2871216" y="2971800"/>
+            <a:off x="2871216" y="3794760"/>
             <a:ext cx="1737360" cy="658368"/>
           </a:xfrm>
           <a:prstGeom prst="roundRect">
@@ -3510,7 +3510,7 @@
         </p:nvSpPr>
         <p:spPr>
           <a:xfrm>
-            <a:off x="969264" y="2971800"/>
+            <a:off x="969264" y="2148840"/>
             <a:ext cx="1737360" cy="658368"/>
           </a:xfrm>
           <a:prstGeom prst="roundRect">
@@ -3564,7 +3564,7 @@
         </p:nvSpPr>
         <p:spPr>
           <a:xfrm>
-            <a:off x="2871216" y="3794760"/>
+            <a:off x="969264" y="2971800"/>
             <a:ext cx="1737360" cy="658368"/>
           </a:xfrm>
           <a:prstGeom prst="roundRect">

</xml_diff>